<commit_message>
Flyers: tighter face crop + dynamic CTA position
- Photo recropped to 1300x1300 centred on face (was 1700x1700);
  reduces foliage on top-left/left of avatar
- CTA y is now Math.min(calloutEnd + 0.25, 9.55) so Step 2 (with
  shorter topics) pulls the sign-up block up to hug the callout,
  while Step 1 (taller topics) stays anchored at 9.55 where it fits

Co-Authored-By: Claude Opus 4.7 (1M context) <noreply@anthropic.com>
</commit_message>
<xml_diff>
--- a/outputs/flyers/USMLE_Step2_Flyer.pptx
+++ b/outputs/flyers/USMLE_Step2_Flyer.pptx
@@ -2707,7 +2707,7 @@
         </p:nvSpPr>
         <p:spPr>
           <a:xfrm>
-            <a:off x="457200" y="8732520"/>
+            <a:off x="457200" y="8449056"/>
             <a:ext cx="6858000" cy="201168"/>
           </a:xfrm>
           <a:prstGeom prst="rect">
@@ -2746,7 +2746,7 @@
         </p:nvSpPr>
         <p:spPr>
           <a:xfrm>
-            <a:off x="457200" y="8915400"/>
+            <a:off x="457200" y="8631936"/>
             <a:ext cx="6858000" cy="402336"/>
           </a:xfrm>
           <a:prstGeom prst="rect">
@@ -2785,7 +2785,7 @@
         </p:nvSpPr>
         <p:spPr>
           <a:xfrm>
-            <a:off x="457200" y="9427464"/>
+            <a:off x="457200" y="9144000"/>
             <a:ext cx="164592" cy="164592"/>
           </a:xfrm>
           <a:prstGeom prst="ellipse">
@@ -2810,7 +2810,7 @@
         </p:nvSpPr>
         <p:spPr>
           <a:xfrm>
-            <a:off x="694944" y="9372600"/>
+            <a:off x="694944" y="9089136"/>
             <a:ext cx="3099816" cy="274320"/>
           </a:xfrm>
           <a:prstGeom prst="rect">
@@ -2857,7 +2857,7 @@
         </p:blipFill>
         <p:spPr>
           <a:xfrm>
-            <a:off x="3977640" y="9390888"/>
+            <a:off x="3977640" y="9107424"/>
             <a:ext cx="237744" cy="237744"/>
           </a:xfrm>
           <a:prstGeom prst="rect">
@@ -2873,7 +2873,7 @@
         </p:nvSpPr>
         <p:spPr>
           <a:xfrm>
-            <a:off x="4288536" y="9372600"/>
+            <a:off x="4288536" y="9089136"/>
             <a:ext cx="2843784" cy="274320"/>
           </a:xfrm>
           <a:prstGeom prst="rect">
@@ -2912,7 +2912,7 @@
         </p:nvSpPr>
         <p:spPr>
           <a:xfrm>
-            <a:off x="457200" y="9665208"/>
+            <a:off x="457200" y="9381744"/>
             <a:ext cx="6858000" cy="164592"/>
           </a:xfrm>
           <a:prstGeom prst="rect">

</xml_diff>